<commit_message>
Add summary visuals and expanded PPTX deck
</commit_message>
<xml_diff>
--- a/reports/GLP1_FAERS_CMPE255.pptx
+++ b/reports/GLP1_FAERS_CMPE255.pptx
@@ -26,9 +26,12 @@
     <p:sldId id="274" r:id="rId20"/>
     <p:sldId id="275" r:id="rId21"/>
     <p:sldId id="276" r:id="rId22"/>
+    <p:sldId id="277" r:id="rId23"/>
+    <p:sldId id="278" r:id="rId24"/>
+    <p:sldId id="279" r:id="rId25"/>
   </p:sldIdLst>
   <p:notesMasterIdLst>
-    <p:notesMasterId r:id="rId23"/>
+    <p:notesMasterId r:id="rId26"/>
   </p:notesMasterIdLst>
   <p:sldSz cx="9144000" cy="5143500"/>
   <p:notesSz cx="5143500" cy="9144000"/>
@@ -2621,6 +2624,277 @@
             <a:fld id="{F7021451-1387-4CA6-816F-3879F97B5CBC}" type="slidenum">
               <a:rPr lang="en-US"/>
               <a:t>21</a:t>
+            </a:fld>
+            <a:endParaRPr lang="en-US"/>
+          </a:p>
+        </p:txBody>
+      </p:sp>
+    </p:spTree>
+    <p:extLst>
+      <p:ext uri="{BB962C8B-B14F-4D97-AF65-F5344CB8AC3E}">
+        <p14:creationId xmlns:p14="http://schemas.microsoft.com/office/powerpoint/2010/main" val="1024086991"/>
+      </p:ext>
+    </p:extLst>
+  </p:cSld>
+  <p:clrMapOvr>
+    <a:masterClrMapping/>
+  </p:clrMapOvr>
+</p:notes>
+</file>
+
+<file path=ppt/notesSlides/notesSlide22.xml><?xml version="1.0" encoding="utf-8"?>
+<p:notes xmlns:a="http://schemas.openxmlformats.org/drawingml/2006/main" xmlns:r="http://schemas.openxmlformats.org/officeDocument/2006/relationships" xmlns:p="http://schemas.openxmlformats.org/presentationml/2006/main">
+  <p:cSld>
+    <p:spTree>
+      <p:nvGrpSpPr>
+        <p:cNvPr id="1" name=""/>
+        <p:cNvGrpSpPr/>
+        <p:nvPr/>
+      </p:nvGrpSpPr>
+      <p:grpSpPr>
+        <a:xfrm>
+          <a:off x="0" y="0"/>
+          <a:ext cx="0" cy="0"/>
+          <a:chOff x="0" y="0"/>
+          <a:chExt cx="0" cy="0"/>
+        </a:xfrm>
+      </p:grpSpPr>
+      <p:sp>
+        <p:nvSpPr>
+          <p:cNvPr id="2" name="Slide Image Placeholder 1"/>
+          <p:cNvSpPr>
+            <a:spLocks noGrp="1" noRot="1" noChangeAspect="1"/>
+          </p:cNvSpPr>
+          <p:nvPr>
+            <p:ph type="sldImg"/>
+          </p:nvPr>
+        </p:nvSpPr>
+        <p:spPr/>
+      </p:sp>
+      <p:sp>
+        <p:nvSpPr>
+          <p:cNvPr id="3" name="Notes Placeholder 2"/>
+          <p:cNvSpPr>
+            <a:spLocks noGrp="1"/>
+          </p:cNvSpPr>
+          <p:nvPr>
+            <p:ph type="body" idx="1"/>
+          </p:nvPr>
+        </p:nvSpPr>
+        <p:spPr/>
+        <p:txBody>
+          <a:bodyPr/>
+          <a:lstStyle/>
+          <a:p>
+            <a:r>
+              <a:rPr lang="en-US" dirty="0"/>
+              <a:t>SPEAKER NOTES — Slide 22 (Star Schema)
+Duration: ~60–75 seconds
+This slide documents the warehousing step required by the rubric. The center fact table captures one unique FAERS case, while the surrounding dimensions store normalized patient demographics, time attributes, outcomes, drugs, and reaction terms. This star design supports fast slice‑and‑dice analysis and provides a clean ETL boundary between raw FAERS tables and modeling-ready features. Emphasize that this structure enables reproducibility and consistent cohort definitions across EDA, mining, and reporting.</a:t>
+            </a:r>
+            <a:endParaRPr lang="en-US" dirty="0"/>
+          </a:p>
+        </p:txBody>
+      </p:sp>
+      <p:sp>
+        <p:nvSpPr>
+          <p:cNvPr id="4" name="Slide Number Placeholder 3"/>
+          <p:cNvSpPr>
+            <a:spLocks noGrp="1"/>
+          </p:cNvSpPr>
+          <p:nvPr>
+            <p:ph type="sldNum" sz="quarter" idx="10"/>
+          </p:nvPr>
+        </p:nvSpPr>
+        <p:spPr/>
+        <p:txBody>
+          <a:bodyPr/>
+          <a:lstStyle/>
+          <a:p>
+            <a:fld id="{F7021451-1387-4CA6-816F-3879F97B5CBC}" type="slidenum">
+              <a:rPr lang="en-US"/>
+              <a:t>22</a:t>
+            </a:fld>
+            <a:endParaRPr lang="en-US"/>
+          </a:p>
+        </p:txBody>
+      </p:sp>
+    </p:spTree>
+    <p:extLst>
+      <p:ext uri="{BB962C8B-B14F-4D97-AF65-F5344CB8AC3E}">
+        <p14:creationId xmlns:p14="http://schemas.microsoft.com/office/powerpoint/2010/main" val="1024086991"/>
+      </p:ext>
+    </p:extLst>
+  </p:cSld>
+  <p:clrMapOvr>
+    <a:masterClrMapping/>
+  </p:clrMapOvr>
+</p:notes>
+</file>
+
+<file path=ppt/notesSlides/notesSlide23.xml><?xml version="1.0" encoding="utf-8"?>
+<p:notes xmlns:a="http://schemas.openxmlformats.org/drawingml/2006/main" xmlns:r="http://schemas.openxmlformats.org/officeDocument/2006/relationships" xmlns:p="http://schemas.openxmlformats.org/presentationml/2006/main">
+  <p:cSld>
+    <p:spTree>
+      <p:nvGrpSpPr>
+        <p:cNvPr id="1" name=""/>
+        <p:cNvGrpSpPr/>
+        <p:nvPr/>
+      </p:nvGrpSpPr>
+      <p:grpSpPr>
+        <a:xfrm>
+          <a:off x="0" y="0"/>
+          <a:ext cx="0" cy="0"/>
+          <a:chOff x="0" y="0"/>
+          <a:chExt cx="0" cy="0"/>
+        </a:xfrm>
+      </p:grpSpPr>
+      <p:sp>
+        <p:nvSpPr>
+          <p:cNvPr id="2" name="Slide Image Placeholder 1"/>
+          <p:cNvSpPr>
+            <a:spLocks noGrp="1" noRot="1" noChangeAspect="1"/>
+          </p:cNvSpPr>
+          <p:nvPr>
+            <p:ph type="sldImg"/>
+          </p:nvPr>
+        </p:nvSpPr>
+        <p:spPr/>
+      </p:sp>
+      <p:sp>
+        <p:nvSpPr>
+          <p:cNvPr id="3" name="Notes Placeholder 2"/>
+          <p:cNvSpPr>
+            <a:spLocks noGrp="1"/>
+          </p:cNvSpPr>
+          <p:nvPr>
+            <p:ph type="body" idx="1"/>
+          </p:nvPr>
+        </p:nvSpPr>
+        <p:spPr/>
+        <p:txBody>
+          <a:bodyPr/>
+          <a:lstStyle/>
+          <a:p>
+            <a:r>
+              <a:rPr lang="en-US" dirty="0"/>
+              <a:t>SPEAKER NOTES — Slide 23 (Model Evaluation)
+Duration: ~90 seconds
+Walk the audience through the performance table on the left: Decision Tree, Naive Bayes, and Random Forest with accuracy, precision, recall, F1, and ROC‑AUC. Emphasize that recall is the primary surveillance metric because missing a severe GI event is the most costly error.
+On the right, interpret the confusion matrix: the threshold‑tuned Random Forest aggressively flags potential severe cases to maximize sensitivity. Acknowledge the precision trade‑off and frame it as acceptable for pharmacovigilance triage workflows.</a:t>
+            </a:r>
+            <a:endParaRPr lang="en-US" dirty="0"/>
+          </a:p>
+        </p:txBody>
+      </p:sp>
+      <p:sp>
+        <p:nvSpPr>
+          <p:cNvPr id="4" name="Slide Number Placeholder 3"/>
+          <p:cNvSpPr>
+            <a:spLocks noGrp="1"/>
+          </p:cNvSpPr>
+          <p:nvPr>
+            <p:ph type="sldNum" sz="quarter" idx="10"/>
+          </p:nvPr>
+        </p:nvSpPr>
+        <p:spPr/>
+        <p:txBody>
+          <a:bodyPr/>
+          <a:lstStyle/>
+          <a:p>
+            <a:fld id="{F7021451-1387-4CA6-816F-3879F97B5CBC}" type="slidenum">
+              <a:rPr lang="en-US"/>
+              <a:t>23</a:t>
+            </a:fld>
+            <a:endParaRPr lang="en-US"/>
+          </a:p>
+        </p:txBody>
+      </p:sp>
+    </p:spTree>
+    <p:extLst>
+      <p:ext uri="{BB962C8B-B14F-4D97-AF65-F5344CB8AC3E}">
+        <p14:creationId xmlns:p14="http://schemas.microsoft.com/office/powerpoint/2010/main" val="1024086991"/>
+      </p:ext>
+    </p:extLst>
+  </p:cSld>
+  <p:clrMapOvr>
+    <a:masterClrMapping/>
+  </p:clrMapOvr>
+</p:notes>
+</file>
+
+<file path=ppt/notesSlides/notesSlide24.xml><?xml version="1.0" encoding="utf-8"?>
+<p:notes xmlns:a="http://schemas.openxmlformats.org/drawingml/2006/main" xmlns:r="http://schemas.openxmlformats.org/officeDocument/2006/relationships" xmlns:p="http://schemas.openxmlformats.org/presentationml/2006/main">
+  <p:cSld>
+    <p:spTree>
+      <p:nvGrpSpPr>
+        <p:cNvPr id="1" name=""/>
+        <p:cNvGrpSpPr/>
+        <p:nvPr/>
+      </p:nvGrpSpPr>
+      <p:grpSpPr>
+        <a:xfrm>
+          <a:off x="0" y="0"/>
+          <a:ext cx="0" cy="0"/>
+          <a:chOff x="0" y="0"/>
+          <a:chExt cx="0" cy="0"/>
+        </a:xfrm>
+      </p:grpSpPr>
+      <p:sp>
+        <p:nvSpPr>
+          <p:cNvPr id="2" name="Slide Image Placeholder 1"/>
+          <p:cNvSpPr>
+            <a:spLocks noGrp="1" noRot="1" noChangeAspect="1"/>
+          </p:cNvSpPr>
+          <p:nvPr>
+            <p:ph type="sldImg"/>
+          </p:nvPr>
+        </p:nvSpPr>
+        <p:spPr/>
+      </p:sp>
+      <p:sp>
+        <p:nvSpPr>
+          <p:cNvPr id="3" name="Notes Placeholder 2"/>
+          <p:cNvSpPr>
+            <a:spLocks noGrp="1"/>
+          </p:cNvSpPr>
+          <p:nvPr>
+            <p:ph type="body" idx="1"/>
+          </p:nvPr>
+        </p:nvSpPr>
+        <p:spPr/>
+        <p:txBody>
+          <a:bodyPr/>
+          <a:lstStyle/>
+          <a:p>
+            <a:r>
+              <a:rPr lang="en-US" dirty="0"/>
+              <a:t>SPEAKER NOTES — Slide 24 (Visual Summary)
+Duration: ~90 seconds
+Use this montage to recap the full analytic story: disproportionality signal (PRR forest), model performance, feature importance, PCA variance distribution, and the warehousing architecture. This slide ties together the rubric requirements by showing that the project covers data warehousing, preprocessing, visualization, data mining, and evaluation. End with a crisp summary: GLP‑1 agents show significant GI signal, a tuned Random Forest provides high‑sensitivity surveillance, and the pipeline is reproducible end‑to‑end.</a:t>
+            </a:r>
+            <a:endParaRPr lang="en-US" dirty="0"/>
+          </a:p>
+        </p:txBody>
+      </p:sp>
+      <p:sp>
+        <p:nvSpPr>
+          <p:cNvPr id="4" name="Slide Number Placeholder 3"/>
+          <p:cNvSpPr>
+            <a:spLocks noGrp="1"/>
+          </p:cNvSpPr>
+          <p:nvPr>
+            <p:ph type="sldNum" sz="quarter" idx="10"/>
+          </p:nvPr>
+        </p:nvSpPr>
+        <p:spPr/>
+        <p:txBody>
+          <a:bodyPr/>
+          <a:lstStyle/>
+          <a:p>
+            <a:fld id="{F7021451-1387-4CA6-816F-3879F97B5CBC}" type="slidenum">
+              <a:rPr lang="en-US"/>
+              <a:t>24</a:t>
             </a:fld>
             <a:endParaRPr lang="en-US"/>
           </a:p>
@@ -4641,7 +4915,7 @@
                   <a:srgbClr val="4A6D87"/>
                 </a:solidFill>
               </a:rPr>
-              <a:t>1 / 21</a:t>
+              <a:t>1 / 24</a:t>
             </a:r>
             <a:endParaRPr lang="en-US" sz="800" dirty="0"/>
           </a:p>
@@ -7150,7 +7424,7 @@
                   <a:srgbClr val="4A6D87"/>
                 </a:solidFill>
               </a:rPr>
-              <a:t>10 / 21</a:t>
+              <a:t>10 / 24</a:t>
             </a:r>
             <a:endParaRPr lang="en-US" sz="800" dirty="0"/>
           </a:p>
@@ -7785,7 +8059,7 @@
                   <a:srgbClr val="4A6D87"/>
                 </a:solidFill>
               </a:rPr>
-              <a:t>11 / 21</a:t>
+              <a:t>11 / 24</a:t>
             </a:r>
             <a:endParaRPr lang="en-US" sz="800" dirty="0"/>
           </a:p>
@@ -9529,7 +9803,7 @@
                   <a:srgbClr val="4A6D87"/>
                 </a:solidFill>
               </a:rPr>
-              <a:t>12 / 21</a:t>
+              <a:t>12 / 24</a:t>
             </a:r>
             <a:endParaRPr lang="en-US" sz="800" dirty="0"/>
           </a:p>
@@ -10597,7 +10871,7 @@
                   <a:srgbClr val="4A6D87"/>
                 </a:solidFill>
               </a:rPr>
-              <a:t>13 / 21</a:t>
+              <a:t>13 / 24</a:t>
             </a:r>
             <a:endParaRPr lang="en-US" sz="800" dirty="0"/>
           </a:p>
@@ -13370,7 +13644,7 @@
                   <a:srgbClr val="4A6D87"/>
                 </a:solidFill>
               </a:rPr>
-              <a:t>14 / 21</a:t>
+              <a:t>14 / 24</a:t>
             </a:r>
             <a:endParaRPr lang="en-US" sz="800" dirty="0"/>
           </a:p>
@@ -14127,7 +14401,7 @@
                   <a:srgbClr val="4A6D87"/>
                 </a:solidFill>
               </a:rPr>
-              <a:t>15 / 21</a:t>
+              <a:t>15 / 24</a:t>
             </a:r>
             <a:endParaRPr lang="en-US" sz="800" dirty="0"/>
           </a:p>
@@ -16665,7 +16939,7 @@
                   <a:srgbClr val="4A6D87"/>
                 </a:solidFill>
               </a:rPr>
-              <a:t>16 / 21</a:t>
+              <a:t>16 / 24</a:t>
             </a:r>
             <a:endParaRPr lang="en-US" sz="800" dirty="0"/>
           </a:p>
@@ -17927,7 +18201,7 @@
                   <a:srgbClr val="4A6D87"/>
                 </a:solidFill>
               </a:rPr>
-              <a:t>17 / 21</a:t>
+              <a:t>17 / 24</a:t>
             </a:r>
             <a:endParaRPr lang="en-US" sz="800" dirty="0"/>
           </a:p>
@@ -20568,7 +20842,7 @@
                   <a:srgbClr val="4A6D87"/>
                 </a:solidFill>
               </a:rPr>
-              <a:t>18 / 21</a:t>
+              <a:t>18 / 24</a:t>
             </a:r>
             <a:endParaRPr lang="en-US" sz="800" dirty="0"/>
           </a:p>
@@ -21925,7 +22199,7 @@
                   <a:srgbClr val="4A6D87"/>
                 </a:solidFill>
               </a:rPr>
-              <a:t>19 / 21</a:t>
+              <a:t>19 / 24</a:t>
             </a:r>
             <a:endParaRPr lang="en-US" sz="800" dirty="0"/>
           </a:p>
@@ -23589,7 +23863,7 @@
                   <a:srgbClr val="4A6D87"/>
                 </a:solidFill>
               </a:rPr>
-              <a:t>2 / 21</a:t>
+              <a:t>2 / 24</a:t>
             </a:r>
             <a:endParaRPr lang="en-US" sz="800" dirty="0"/>
           </a:p>
@@ -24386,7 +24660,7 @@
                   <a:srgbClr val="4A6D87"/>
                 </a:solidFill>
               </a:rPr>
-              <a:t>20 / 21</a:t>
+              <a:t>20 / 24</a:t>
             </a:r>
             <a:endParaRPr lang="en-US" sz="800" dirty="0"/>
           </a:p>
@@ -25489,7 +25763,556 @@
                   <a:srgbClr val="4A6D87"/>
                 </a:solidFill>
               </a:rPr>
-              <a:t>21 / 21</a:t>
+              <a:t>21 / 24</a:t>
+            </a:r>
+            <a:endParaRPr lang="en-US" sz="800" dirty="0"/>
+          </a:p>
+        </p:txBody>
+      </p:sp>
+    </p:spTree>
+  </p:cSld>
+  <p:clrMapOvr>
+    <a:masterClrMapping/>
+  </p:clrMapOvr>
+</p:sld>
+</file>
+
+<file path=ppt/slides/slide22.xml><?xml version="1.0" encoding="utf-8"?>
+<p:sld xmlns:a="http://schemas.openxmlformats.org/drawingml/2006/main" xmlns:r="http://schemas.openxmlformats.org/officeDocument/2006/relationships" xmlns:p="http://schemas.openxmlformats.org/presentationml/2006/main">
+  <p:cSld name="Slide 22">
+    <p:spTree>
+      <p:nvGrpSpPr>
+        <p:cNvPr id="1" name=""/>
+        <p:cNvGrpSpPr/>
+        <p:nvPr/>
+      </p:nvGrpSpPr>
+      <p:grpSpPr>
+        <a:xfrm>
+          <a:off x="0" y="0"/>
+          <a:ext cx="0" cy="0"/>
+          <a:chOff x="0" y="0"/>
+          <a:chExt cx="0" cy="0"/>
+        </a:xfrm>
+      </p:grpSpPr>
+      <p:sp>
+        <p:nvSpPr>
+          <p:cNvPr id="2" name="Shape 0"/>
+          <p:cNvSpPr/>
+          <p:nvPr/>
+        </p:nvSpPr>
+        <p:spPr>
+          <a:xfrm>
+            <a:off x="0" y="0"/>
+            <a:ext cx="9144000" cy="502920"/>
+          </a:xfrm>
+          <a:prstGeom prst="rect">
+            <a:avLst/>
+          </a:prstGeom>
+          <a:solidFill>
+            <a:srgbClr val="0F2040"/>
+          </a:solidFill>
+          <a:ln w="12700">
+            <a:solidFill>
+              <a:srgbClr val="0F2040"/>
+            </a:solidFill>
+            <a:prstDash val="solid"/>
+          </a:ln>
+        </p:spPr>
+      </p:sp>
+      <p:sp>
+        <p:nvSpPr>
+          <p:cNvPr id="3" name="Text 1"/>
+          <p:cNvSpPr/>
+          <p:nvPr/>
+        </p:nvSpPr>
+        <p:spPr>
+          <a:xfrm>
+            <a:off x="365760" y="73152"/>
+            <a:ext cx="8412480" cy="365760"/>
+          </a:xfrm>
+          <a:prstGeom prst="rect">
+            <a:avLst/>
+          </a:prstGeom>
+          <a:noFill/>
+          <a:ln/>
+        </p:spPr>
+        <p:txBody>
+          <a:bodyPr wrap="square" rtlCol="0" anchor="ctr"/>
+          <a:lstStyle/>
+          <a:p>
+            <a:pPr indent="0" marL="0">
+              <a:buNone/>
+            </a:pPr>
+            <a:r>
+              <a:rPr lang="en-US" sz="2000" b="1" dirty="0">
+                <a:solidFill>
+                  <a:srgbClr val="FFFFFF"/>
+                </a:solidFill>
+                <a:latin typeface="Calibri" pitchFamily="34" charset="0"/>
+                <a:ea typeface="Calibri" pitchFamily="34" charset="-122"/>
+                <a:cs typeface="Calibri" pitchFamily="34" charset="-120"/>
+              </a:rPr>
+              <a:t>DATA WAREHOUSE DESIGN (STAR SCHEMA)</a:t>
+            </a:r>
+            <a:endParaRPr lang="en-US" sz="2000" dirty="0"/>
+          </a:p>
+        </p:txBody>
+      </p:sp>
+      <p:pic>
+        <p:nvPicPr>
+          <p:cNvPr id="4" name="Image 0" descr="preencoded.png">    </p:cNvPr>
+          <p:cNvPicPr>
+            <a:picLocks noChangeAspect="1"/>
+          </p:cNvPicPr>
+          <p:nvPr/>
+        </p:nvPicPr>
+        <p:blipFill>
+          <a:blip r:embed="rId1"/>
+          <a:stretch>
+            <a:fillRect/>
+          </a:stretch>
+        </p:blipFill>
+        <p:spPr>
+          <a:xfrm>
+            <a:off x="548640" y="1188720"/>
+            <a:ext cx="8046720" cy="4206240"/>
+          </a:xfrm>
+          <a:prstGeom prst="rect">
+            <a:avLst/>
+          </a:prstGeom>
+        </p:spPr>
+      </p:pic>
+      <p:sp>
+        <p:nvSpPr>
+          <p:cNvPr id="5" name="Text 2"/>
+          <p:cNvSpPr/>
+          <p:nvPr/>
+        </p:nvSpPr>
+        <p:spPr>
+          <a:xfrm>
+            <a:off x="548640" y="5577840"/>
+            <a:ext cx="8046720" cy="365760"/>
+          </a:xfrm>
+          <a:prstGeom prst="rect">
+            <a:avLst/>
+          </a:prstGeom>
+          <a:noFill/>
+          <a:ln/>
+        </p:spPr>
+        <p:txBody>
+          <a:bodyPr wrap="square" rtlCol="0" anchor="ctr"/>
+          <a:lstStyle/>
+          <a:p>
+            <a:pPr algn="ctr" indent="0" marL="0">
+              <a:buNone/>
+            </a:pPr>
+            <a:r>
+              <a:rPr lang="en-US" sz="1100" dirty="0">
+                <a:solidFill>
+                  <a:srgbClr val="8BAFC8"/>
+                </a:solidFill>
+                <a:latin typeface="Calibri" pitchFamily="34" charset="0"/>
+                <a:ea typeface="Calibri" pitchFamily="34" charset="-122"/>
+                <a:cs typeface="Calibri" pitchFamily="34" charset="-120"/>
+              </a:rPr>
+              <a:t>Fact table: adverse event case | Dimensions: patient, time, outcome, drug, reaction</a:t>
+            </a:r>
+            <a:endParaRPr lang="en-US" sz="1100" dirty="0"/>
+          </a:p>
+        </p:txBody>
+      </p:sp>
+      <p:sp>
+        <p:nvSpPr>
+          <p:cNvPr id="6" name="Text 3"/>
+          <p:cNvSpPr/>
+          <p:nvPr/>
+        </p:nvSpPr>
+        <p:spPr>
+          <a:xfrm>
+            <a:off x="8229600" y="4850892"/>
+            <a:ext cx="731520" cy="201168"/>
+          </a:xfrm>
+          <a:prstGeom prst="rect">
+            <a:avLst/>
+          </a:prstGeom>
+          <a:noFill/>
+          <a:ln/>
+        </p:spPr>
+        <p:txBody>
+          <a:bodyPr wrap="square" rtlCol="0" anchor="ctr"/>
+          <a:lstStyle/>
+          <a:p>
+            <a:pPr algn="r" indent="0" marL="0">
+              <a:buNone/>
+            </a:pPr>
+            <a:r>
+              <a:rPr lang="en-US" sz="800" dirty="0">
+                <a:solidFill>
+                  <a:srgbClr val="4A6D87"/>
+                </a:solidFill>
+              </a:rPr>
+              <a:t>22 / 24</a:t>
+            </a:r>
+            <a:endParaRPr lang="en-US" sz="800" dirty="0"/>
+          </a:p>
+        </p:txBody>
+      </p:sp>
+    </p:spTree>
+  </p:cSld>
+  <p:clrMapOvr>
+    <a:masterClrMapping/>
+  </p:clrMapOvr>
+</p:sld>
+</file>
+
+<file path=ppt/slides/slide23.xml><?xml version="1.0" encoding="utf-8"?>
+<p:sld xmlns:a="http://schemas.openxmlformats.org/drawingml/2006/main" xmlns:r="http://schemas.openxmlformats.org/officeDocument/2006/relationships" xmlns:p="http://schemas.openxmlformats.org/presentationml/2006/main">
+  <p:cSld name="Slide 23">
+    <p:spTree>
+      <p:nvGrpSpPr>
+        <p:cNvPr id="1" name=""/>
+        <p:cNvGrpSpPr/>
+        <p:nvPr/>
+      </p:nvGrpSpPr>
+      <p:grpSpPr>
+        <a:xfrm>
+          <a:off x="0" y="0"/>
+          <a:ext cx="0" cy="0"/>
+          <a:chOff x="0" y="0"/>
+          <a:chExt cx="0" cy="0"/>
+        </a:xfrm>
+      </p:grpSpPr>
+      <p:sp>
+        <p:nvSpPr>
+          <p:cNvPr id="2" name="Shape 0"/>
+          <p:cNvSpPr/>
+          <p:nvPr/>
+        </p:nvSpPr>
+        <p:spPr>
+          <a:xfrm>
+            <a:off x="0" y="0"/>
+            <a:ext cx="9144000" cy="502920"/>
+          </a:xfrm>
+          <a:prstGeom prst="rect">
+            <a:avLst/>
+          </a:prstGeom>
+          <a:solidFill>
+            <a:srgbClr val="0F2040"/>
+          </a:solidFill>
+          <a:ln w="12700">
+            <a:solidFill>
+              <a:srgbClr val="0F2040"/>
+            </a:solidFill>
+            <a:prstDash val="solid"/>
+          </a:ln>
+        </p:spPr>
+      </p:sp>
+      <p:sp>
+        <p:nvSpPr>
+          <p:cNvPr id="3" name="Text 1"/>
+          <p:cNvSpPr/>
+          <p:nvPr/>
+        </p:nvSpPr>
+        <p:spPr>
+          <a:xfrm>
+            <a:off x="365760" y="73152"/>
+            <a:ext cx="8412480" cy="365760"/>
+          </a:xfrm>
+          <a:prstGeom prst="rect">
+            <a:avLst/>
+          </a:prstGeom>
+          <a:noFill/>
+          <a:ln/>
+        </p:spPr>
+        <p:txBody>
+          <a:bodyPr wrap="square" rtlCol="0" anchor="ctr"/>
+          <a:lstStyle/>
+          <a:p>
+            <a:pPr indent="0" marL="0">
+              <a:buNone/>
+            </a:pPr>
+            <a:r>
+              <a:rPr lang="en-US" sz="2000" b="1" dirty="0">
+                <a:solidFill>
+                  <a:srgbClr val="FFFFFF"/>
+                </a:solidFill>
+                <a:latin typeface="Calibri" pitchFamily="34" charset="0"/>
+                <a:ea typeface="Calibri" pitchFamily="34" charset="-122"/>
+                <a:cs typeface="Calibri" pitchFamily="34" charset="-120"/>
+              </a:rPr>
+              <a:t>MODEL EVALUATION &amp; PERFORMANCE</a:t>
+            </a:r>
+            <a:endParaRPr lang="en-US" sz="2000" dirty="0"/>
+          </a:p>
+        </p:txBody>
+      </p:sp>
+      <p:pic>
+        <p:nvPicPr>
+          <p:cNvPr id="4" name="Image 0" descr="preencoded.png">    </p:cNvPr>
+          <p:cNvPicPr>
+            <a:picLocks noChangeAspect="1"/>
+          </p:cNvPicPr>
+          <p:nvPr/>
+        </p:nvPicPr>
+        <p:blipFill>
+          <a:blip r:embed="rId1"/>
+          <a:stretch>
+            <a:fillRect/>
+          </a:stretch>
+        </p:blipFill>
+        <p:spPr>
+          <a:xfrm>
+            <a:off x="548640" y="1188720"/>
+            <a:ext cx="4023360" cy="4206240"/>
+          </a:xfrm>
+          <a:prstGeom prst="rect">
+            <a:avLst/>
+          </a:prstGeom>
+        </p:spPr>
+      </p:pic>
+      <p:pic>
+        <p:nvPicPr>
+          <p:cNvPr id="5" name="Image 1" descr="preencoded.png">    </p:cNvPr>
+          <p:cNvPicPr>
+            <a:picLocks noChangeAspect="1"/>
+          </p:cNvPicPr>
+          <p:nvPr/>
+        </p:nvPicPr>
+        <p:blipFill>
+          <a:blip r:embed="rId2"/>
+          <a:stretch>
+            <a:fillRect/>
+          </a:stretch>
+        </p:blipFill>
+        <p:spPr>
+          <a:xfrm>
+            <a:off x="4754880" y="1188720"/>
+            <a:ext cx="3931920" cy="4206240"/>
+          </a:xfrm>
+          <a:prstGeom prst="rect">
+            <a:avLst/>
+          </a:prstGeom>
+        </p:spPr>
+      </p:pic>
+      <p:sp>
+        <p:nvSpPr>
+          <p:cNvPr id="6" name="Text 2"/>
+          <p:cNvSpPr/>
+          <p:nvPr/>
+        </p:nvSpPr>
+        <p:spPr>
+          <a:xfrm>
+            <a:off x="548640" y="5577840"/>
+            <a:ext cx="8046720" cy="365760"/>
+          </a:xfrm>
+          <a:prstGeom prst="rect">
+            <a:avLst/>
+          </a:prstGeom>
+          <a:noFill/>
+          <a:ln/>
+        </p:spPr>
+        <p:txBody>
+          <a:bodyPr wrap="square" rtlCol="0" anchor="ctr"/>
+          <a:lstStyle/>
+          <a:p>
+            <a:pPr algn="ctr" indent="0" marL="0">
+              <a:buNone/>
+            </a:pPr>
+            <a:r>
+              <a:rPr lang="en-US" sz="1100" dirty="0">
+                <a:solidFill>
+                  <a:srgbClr val="8BAFC8"/>
+                </a:solidFill>
+                <a:latin typeface="Calibri" pitchFamily="34" charset="0"/>
+                <a:ea typeface="Calibri" pitchFamily="34" charset="-122"/>
+                <a:cs typeface="Calibri" pitchFamily="34" charset="-120"/>
+              </a:rPr>
+              <a:t>Threshold‑tuned Random Forest prioritized sensitivity for rare severe events.</a:t>
+            </a:r>
+            <a:endParaRPr lang="en-US" sz="1100" dirty="0"/>
+          </a:p>
+        </p:txBody>
+      </p:sp>
+      <p:sp>
+        <p:nvSpPr>
+          <p:cNvPr id="7" name="Text 3"/>
+          <p:cNvSpPr/>
+          <p:nvPr/>
+        </p:nvSpPr>
+        <p:spPr>
+          <a:xfrm>
+            <a:off x="8229600" y="4850892"/>
+            <a:ext cx="731520" cy="201168"/>
+          </a:xfrm>
+          <a:prstGeom prst="rect">
+            <a:avLst/>
+          </a:prstGeom>
+          <a:noFill/>
+          <a:ln/>
+        </p:spPr>
+        <p:txBody>
+          <a:bodyPr wrap="square" rtlCol="0" anchor="ctr"/>
+          <a:lstStyle/>
+          <a:p>
+            <a:pPr algn="r" indent="0" marL="0">
+              <a:buNone/>
+            </a:pPr>
+            <a:r>
+              <a:rPr lang="en-US" sz="800" dirty="0">
+                <a:solidFill>
+                  <a:srgbClr val="4A6D87"/>
+                </a:solidFill>
+              </a:rPr>
+              <a:t>23 / 24</a:t>
+            </a:r>
+            <a:endParaRPr lang="en-US" sz="800" dirty="0"/>
+          </a:p>
+        </p:txBody>
+      </p:sp>
+    </p:spTree>
+  </p:cSld>
+  <p:clrMapOvr>
+    <a:masterClrMapping/>
+  </p:clrMapOvr>
+</p:sld>
+</file>
+
+<file path=ppt/slides/slide24.xml><?xml version="1.0" encoding="utf-8"?>
+<p:sld xmlns:a="http://schemas.openxmlformats.org/drawingml/2006/main" xmlns:r="http://schemas.openxmlformats.org/officeDocument/2006/relationships" xmlns:p="http://schemas.openxmlformats.org/presentationml/2006/main">
+  <p:cSld name="Slide 24">
+    <p:spTree>
+      <p:nvGrpSpPr>
+        <p:cNvPr id="1" name=""/>
+        <p:cNvGrpSpPr/>
+        <p:nvPr/>
+      </p:nvGrpSpPr>
+      <p:grpSpPr>
+        <a:xfrm>
+          <a:off x="0" y="0"/>
+          <a:ext cx="0" cy="0"/>
+          <a:chOff x="0" y="0"/>
+          <a:chExt cx="0" cy="0"/>
+        </a:xfrm>
+      </p:grpSpPr>
+      <p:sp>
+        <p:nvSpPr>
+          <p:cNvPr id="2" name="Shape 0"/>
+          <p:cNvSpPr/>
+          <p:nvPr/>
+        </p:nvSpPr>
+        <p:spPr>
+          <a:xfrm>
+            <a:off x="0" y="0"/>
+            <a:ext cx="9144000" cy="502920"/>
+          </a:xfrm>
+          <a:prstGeom prst="rect">
+            <a:avLst/>
+          </a:prstGeom>
+          <a:solidFill>
+            <a:srgbClr val="0F2040"/>
+          </a:solidFill>
+          <a:ln w="12700">
+            <a:solidFill>
+              <a:srgbClr val="0F2040"/>
+            </a:solidFill>
+            <a:prstDash val="solid"/>
+          </a:ln>
+        </p:spPr>
+      </p:sp>
+      <p:sp>
+        <p:nvSpPr>
+          <p:cNvPr id="3" name="Text 1"/>
+          <p:cNvSpPr/>
+          <p:nvPr/>
+        </p:nvSpPr>
+        <p:spPr>
+          <a:xfrm>
+            <a:off x="365760" y="73152"/>
+            <a:ext cx="8412480" cy="365760"/>
+          </a:xfrm>
+          <a:prstGeom prst="rect">
+            <a:avLst/>
+          </a:prstGeom>
+          <a:noFill/>
+          <a:ln/>
+        </p:spPr>
+        <p:txBody>
+          <a:bodyPr wrap="square" rtlCol="0" anchor="ctr"/>
+          <a:lstStyle/>
+          <a:p>
+            <a:pPr indent="0" marL="0">
+              <a:buNone/>
+            </a:pPr>
+            <a:r>
+              <a:rPr lang="en-US" sz="2000" b="1" dirty="0">
+                <a:solidFill>
+                  <a:srgbClr val="FFFFFF"/>
+                </a:solidFill>
+                <a:latin typeface="Calibri" pitchFamily="34" charset="0"/>
+                <a:ea typeface="Calibri" pitchFamily="34" charset="-122"/>
+                <a:cs typeface="Calibri" pitchFamily="34" charset="-120"/>
+              </a:rPr>
+              <a:t>VISUAL SUMMARY — KEY FINDINGS</a:t>
+            </a:r>
+            <a:endParaRPr lang="en-US" sz="2000" dirty="0"/>
+          </a:p>
+        </p:txBody>
+      </p:sp>
+      <p:pic>
+        <p:nvPicPr>
+          <p:cNvPr id="4" name="Image 0" descr="preencoded.png">    </p:cNvPr>
+          <p:cNvPicPr>
+            <a:picLocks noChangeAspect="1"/>
+          </p:cNvPicPr>
+          <p:nvPr/>
+        </p:nvPicPr>
+        <p:blipFill>
+          <a:blip r:embed="rId1"/>
+          <a:stretch>
+            <a:fillRect/>
+          </a:stretch>
+        </p:blipFill>
+        <p:spPr>
+          <a:xfrm>
+            <a:off x="365760" y="1005840"/>
+            <a:ext cx="8412480" cy="5120640"/>
+          </a:xfrm>
+          <a:prstGeom prst="rect">
+            <a:avLst/>
+          </a:prstGeom>
+        </p:spPr>
+      </p:pic>
+      <p:sp>
+        <p:nvSpPr>
+          <p:cNvPr id="5" name="Text 2"/>
+          <p:cNvSpPr/>
+          <p:nvPr/>
+        </p:nvSpPr>
+        <p:spPr>
+          <a:xfrm>
+            <a:off x="8229600" y="4850892"/>
+            <a:ext cx="731520" cy="201168"/>
+          </a:xfrm>
+          <a:prstGeom prst="rect">
+            <a:avLst/>
+          </a:prstGeom>
+          <a:noFill/>
+          <a:ln/>
+        </p:spPr>
+        <p:txBody>
+          <a:bodyPr wrap="square" rtlCol="0" anchor="ctr"/>
+          <a:lstStyle/>
+          <a:p>
+            <a:pPr algn="r" indent="0" marL="0">
+              <a:buNone/>
+            </a:pPr>
+            <a:r>
+              <a:rPr lang="en-US" sz="800" dirty="0">
+                <a:solidFill>
+                  <a:srgbClr val="4A6D87"/>
+                </a:solidFill>
+              </a:rPr>
+              <a:t>24 / 24</a:t>
             </a:r>
             <a:endParaRPr lang="en-US" sz="800" dirty="0"/>
           </a:p>
@@ -26537,7 +27360,7 @@
                   <a:srgbClr val="4A6D87"/>
                 </a:solidFill>
               </a:rPr>
-              <a:t>3 / 21</a:t>
+              <a:t>3 / 24</a:t>
             </a:r>
             <a:endParaRPr lang="en-US" sz="800" dirty="0"/>
           </a:p>
@@ -27437,7 +28260,7 @@
                   <a:srgbClr val="4A6D87"/>
                 </a:solidFill>
               </a:rPr>
-              <a:t>4 / 21</a:t>
+              <a:t>4 / 24</a:t>
             </a:r>
             <a:endParaRPr lang="en-US" sz="800" dirty="0"/>
           </a:p>
@@ -28647,7 +29470,7 @@
                   <a:srgbClr val="4A6D87"/>
                 </a:solidFill>
               </a:rPr>
-              <a:t>5 / 21</a:t>
+              <a:t>5 / 24</a:t>
             </a:r>
             <a:endParaRPr lang="en-US" sz="800" dirty="0"/>
           </a:p>
@@ -30219,7 +31042,7 @@
                   <a:srgbClr val="4A6D87"/>
                 </a:solidFill>
               </a:rPr>
-              <a:t>6 / 21</a:t>
+              <a:t>6 / 24</a:t>
             </a:r>
             <a:endParaRPr lang="en-US" sz="800" dirty="0"/>
           </a:p>
@@ -32060,7 +32883,7 @@
                   <a:srgbClr val="4A6D87"/>
                 </a:solidFill>
               </a:rPr>
-              <a:t>7 / 21</a:t>
+              <a:t>7 / 24</a:t>
             </a:r>
             <a:endParaRPr lang="en-US" sz="800" dirty="0"/>
           </a:p>
@@ -33202,7 +34025,7 @@
                   <a:srgbClr val="4A6D87"/>
                 </a:solidFill>
               </a:rPr>
-              <a:t>8 / 21</a:t>
+              <a:t>8 / 24</a:t>
             </a:r>
             <a:endParaRPr lang="en-US" sz="800" dirty="0"/>
           </a:p>
@@ -33913,7 +34736,7 @@
                   <a:srgbClr val="4A6D87"/>
                 </a:solidFill>
               </a:rPr>
-              <a:t>9 / 21</a:t>
+              <a:t>9 / 24</a:t>
             </a:r>
             <a:endParaRPr lang="en-US" sz="800" dirty="0"/>
           </a:p>

</xml_diff>